<commit_message>
test: baselines for invisible text, baselines, page breaks and the ODP namespace
</commit_message>
<xml_diff>
--- a/test/generator/baseline/gen.pdf.to.pptx.pptx
+++ b/test/generator/baseline/gen.pdf.to.pptx.pptx
@@ -100,8 +100,8 @@
         </p:nvSpPr>
         <p:spPr>
           <a:xfrm>
-            <a:off x="914781" y="924560"/>
-            <a:ext cx="5343906" cy="748284"/>
+            <a:off x="914781" y="920242"/>
+            <a:ext cx="5343906" cy="756158"/>
           </a:xfrm>
           <a:prstGeom prst="rect">
             <a:avLst/>
@@ -156,8 +156,8 @@
         </p:nvSpPr>
         <p:spPr>
           <a:xfrm>
-            <a:off x="914781" y="1931924"/>
-            <a:ext cx="5477002" cy="774446"/>
+            <a:off x="914781" y="1903180"/>
+            <a:ext cx="5477002" cy="804841"/>
           </a:xfrm>
           <a:prstGeom prst="rect">
             <a:avLst/>
@@ -224,8 +224,8 @@
         </p:nvSpPr>
         <p:spPr>
           <a:xfrm>
-            <a:off x="914781" y="2738755"/>
-            <a:ext cx="5891276" cy="370840"/>
+            <a:off x="914781" y="2711196"/>
+            <a:ext cx="5891276" cy="400050"/>
           </a:xfrm>
           <a:prstGeom prst="rect">
             <a:avLst/>
@@ -274,8 +274,8 @@
         </p:nvSpPr>
         <p:spPr>
           <a:xfrm>
-            <a:off x="914781" y="3141980"/>
-            <a:ext cx="5874385" cy="571119"/>
+            <a:off x="914781" y="3114294"/>
+            <a:ext cx="5874385" cy="600456"/>
           </a:xfrm>
           <a:prstGeom prst="rect">
             <a:avLst/>
@@ -388,8 +388,8 @@
         </p:nvSpPr>
         <p:spPr>
           <a:xfrm>
-            <a:off x="3192145" y="1225296"/>
-            <a:ext cx="1387729" cy="199263"/>
+            <a:off x="3192145" y="1213231"/>
+            <a:ext cx="1387729" cy="213360"/>
           </a:xfrm>
           <a:prstGeom prst="rect">
             <a:avLst/>
@@ -406,6 +406,9 @@
           <a:lstStyle/>
           <a:p>
             <a:pPr>
+              <a:lnSpc>
+                <a:spcPts val="1680"/>
+              </a:lnSpc>
               <a:buNone/>
             </a:pPr>
             <a:r>
@@ -429,8 +432,8 @@
         </p:nvSpPr>
         <p:spPr>
           <a:xfrm>
-            <a:off x="914781" y="1586611"/>
-            <a:ext cx="1348105" cy="185039"/>
+            <a:off x="914781" y="1575435"/>
+            <a:ext cx="1348105" cy="198120"/>
           </a:xfrm>
           <a:prstGeom prst="rect">
             <a:avLst/>
@@ -447,6 +450,9 @@
           <a:lstStyle/>
           <a:p>
             <a:pPr>
+              <a:lnSpc>
+                <a:spcPts val="1560"/>
+              </a:lnSpc>
               <a:buNone/>
             </a:pPr>
             <a:r>
@@ -470,8 +476,8 @@
         </p:nvSpPr>
         <p:spPr>
           <a:xfrm>
-            <a:off x="914781" y="1804924"/>
-            <a:ext cx="5492750" cy="370840"/>
+            <a:off x="914781" y="1777365"/>
+            <a:ext cx="5492750" cy="400050"/>
           </a:xfrm>
           <a:prstGeom prst="rect">
             <a:avLst/>
@@ -520,8 +526,8 @@
         </p:nvSpPr>
         <p:spPr>
           <a:xfrm>
-            <a:off x="914781" y="2208149"/>
-            <a:ext cx="5869305" cy="577596"/>
+            <a:off x="914781" y="2177225"/>
+            <a:ext cx="5869305" cy="610171"/>
           </a:xfrm>
           <a:prstGeom prst="rect">
             <a:avLst/>
@@ -627,8 +633,8 @@
         </p:nvSpPr>
         <p:spPr>
           <a:xfrm>
-            <a:off x="914781" y="2824480"/>
-            <a:ext cx="5935091" cy="777494"/>
+            <a:off x="914781" y="2794720"/>
+            <a:ext cx="5935091" cy="808905"/>
           </a:xfrm>
           <a:prstGeom prst="rect">
             <a:avLst/>
@@ -725,8 +731,8 @@
         </p:nvSpPr>
         <p:spPr>
           <a:xfrm>
-            <a:off x="914781" y="3758946"/>
-            <a:ext cx="1139571" cy="185039"/>
+            <a:off x="914781" y="3747770"/>
+            <a:ext cx="1139571" cy="198120"/>
           </a:xfrm>
           <a:prstGeom prst="rect">
             <a:avLst/>
@@ -743,6 +749,9 @@
           <a:lstStyle/>
           <a:p>
             <a:pPr>
+              <a:lnSpc>
+                <a:spcPts val="1560"/>
+              </a:lnSpc>
               <a:buNone/>
             </a:pPr>
             <a:r>
@@ -766,8 +775,8 @@
         </p:nvSpPr>
         <p:spPr>
           <a:xfrm>
-            <a:off x="914781" y="3977259"/>
-            <a:ext cx="5919978" cy="774319"/>
+            <a:off x="914781" y="3948557"/>
+            <a:ext cx="5919978" cy="804672"/>
           </a:xfrm>
           <a:prstGeom prst="rect">
             <a:avLst/>
@@ -846,8 +855,8 @@
         </p:nvSpPr>
         <p:spPr>
           <a:xfrm>
-            <a:off x="914781" y="4911725"/>
-            <a:ext cx="2144268" cy="185039"/>
+            <a:off x="914781" y="4900549"/>
+            <a:ext cx="2144268" cy="198120"/>
           </a:xfrm>
           <a:prstGeom prst="rect">
             <a:avLst/>
@@ -864,6 +873,9 @@
           <a:lstStyle/>
           <a:p>
             <a:pPr>
+              <a:lnSpc>
+                <a:spcPts val="1560"/>
+              </a:lnSpc>
               <a:buNone/>
             </a:pPr>
             <a:r>
@@ -887,8 +899,8 @@
         </p:nvSpPr>
         <p:spPr>
           <a:xfrm>
-            <a:off x="1181735" y="5126863"/>
-            <a:ext cx="5674233" cy="374015"/>
+            <a:off x="1181735" y="5096129"/>
+            <a:ext cx="5674233" cy="406400"/>
           </a:xfrm>
           <a:prstGeom prst="rect">
             <a:avLst/>
@@ -937,8 +949,8 @@
         </p:nvSpPr>
         <p:spPr>
           <a:xfrm>
-            <a:off x="6003290" y="5530469"/>
-            <a:ext cx="858901" cy="170815"/>
+            <a:off x="6003290" y="5501132"/>
+            <a:ext cx="858901" cy="201803"/>
           </a:xfrm>
           <a:prstGeom prst="rect">
             <a:avLst/>
@@ -978,8 +990,8 @@
         </p:nvSpPr>
         <p:spPr>
           <a:xfrm>
-            <a:off x="914781" y="6114669"/>
-            <a:ext cx="5917946" cy="974344"/>
+            <a:off x="914781" y="6086253"/>
+            <a:ext cx="5917946" cy="1004411"/>
           </a:xfrm>
           <a:prstGeom prst="rect">
             <a:avLst/>
@@ -1080,8 +1092,8 @@
         </p:nvSpPr>
         <p:spPr>
           <a:xfrm>
-            <a:off x="3605276" y="1225296"/>
-            <a:ext cx="561848" cy="199263"/>
+            <a:off x="3605276" y="1213231"/>
+            <a:ext cx="561848" cy="213360"/>
           </a:xfrm>
           <a:prstGeom prst="rect">
             <a:avLst/>
@@ -1098,6 +1110,9 @@
           <a:lstStyle/>
           <a:p>
             <a:pPr>
+              <a:lnSpc>
+                <a:spcPts val="1680"/>
+              </a:lnSpc>
               <a:buNone/>
             </a:pPr>
             <a:r>
@@ -1649,8 +1664,8 @@
         </p:nvSpPr>
         <p:spPr>
           <a:xfrm>
-            <a:off x="3154045" y="1458849"/>
-            <a:ext cx="3577844" cy="1177671"/>
+            <a:off x="3154045" y="1429944"/>
+            <a:ext cx="3577844" cy="1208227"/>
           </a:xfrm>
           <a:prstGeom prst="rect">
             <a:avLst/>
@@ -1735,8 +1750,8 @@
         </p:nvSpPr>
         <p:spPr>
           <a:xfrm>
-            <a:off x="914781" y="2668905"/>
-            <a:ext cx="5924804" cy="570865"/>
+            <a:off x="914781" y="2641346"/>
+            <a:ext cx="5924804" cy="600075"/>
           </a:xfrm>
           <a:prstGeom prst="rect">
             <a:avLst/>
@@ -1794,8 +1809,8 @@
         </p:nvSpPr>
         <p:spPr>
           <a:xfrm>
-            <a:off x="914781" y="3272028"/>
-            <a:ext cx="5542788" cy="371221"/>
+            <a:off x="914781" y="3244088"/>
+            <a:ext cx="5542788" cy="400812"/>
           </a:xfrm>
           <a:prstGeom prst="rect">
             <a:avLst/>
@@ -3297,8 +3312,8 @@
         </p:nvSpPr>
         <p:spPr>
           <a:xfrm>
-            <a:off x="914781" y="5190363"/>
-            <a:ext cx="5783580" cy="371221"/>
+            <a:off x="914781" y="5162423"/>
+            <a:ext cx="5783580" cy="400812"/>
           </a:xfrm>
           <a:prstGeom prst="rect">
             <a:avLst/>
@@ -4672,8 +4687,8 @@
         </p:nvSpPr>
         <p:spPr>
           <a:xfrm>
-            <a:off x="914781" y="7939151"/>
-            <a:ext cx="2982214" cy="142367"/>
+            <a:off x="914781" y="7930515"/>
+            <a:ext cx="2982214" cy="152400"/>
           </a:xfrm>
           <a:prstGeom prst="rect">
             <a:avLst/>
@@ -4690,6 +4705,9 @@
           <a:lstStyle/>
           <a:p>
             <a:pPr>
+              <a:lnSpc>
+                <a:spcPts val="1200"/>
+              </a:lnSpc>
               <a:buNone/>
             </a:pPr>
             <a:r>
@@ -4716,8 +4734,8 @@
         </p:nvSpPr>
         <p:spPr>
           <a:xfrm>
-            <a:off x="914781" y="8239379"/>
-            <a:ext cx="5792978" cy="574294"/>
+            <a:off x="914781" y="8210106"/>
+            <a:ext cx="5792978" cy="605218"/>
           </a:xfrm>
           <a:prstGeom prst="rect">
             <a:avLst/>
@@ -4926,8 +4944,8 @@
         </p:nvSpPr>
         <p:spPr>
           <a:xfrm>
-            <a:off x="914781" y="2122424"/>
-            <a:ext cx="5913247" cy="774446"/>
+            <a:off x="914781" y="2093680"/>
+            <a:ext cx="5913247" cy="804841"/>
           </a:xfrm>
           <a:prstGeom prst="rect">
             <a:avLst/>
@@ -4994,8 +5012,8 @@
         </p:nvSpPr>
         <p:spPr>
           <a:xfrm>
-            <a:off x="4189730" y="2931541"/>
-            <a:ext cx="2007235" cy="313182"/>
+            <a:off x="4189730" y="2912491"/>
+            <a:ext cx="2007235" cy="335280"/>
           </a:xfrm>
           <a:prstGeom prst="rect">
             <a:avLst/>
@@ -5012,6 +5030,9 @@
           <a:lstStyle/>
           <a:p>
             <a:pPr>
+              <a:lnSpc>
+                <a:spcPts val="2640"/>
+              </a:lnSpc>
               <a:buNone/>
             </a:pPr>
             <a:r>
@@ -7254,8 +7275,8 @@
         </p:nvSpPr>
         <p:spPr>
           <a:xfrm>
-            <a:off x="3036570" y="1225296"/>
-            <a:ext cx="1703451" cy="199263"/>
+            <a:off x="3036570" y="1213231"/>
+            <a:ext cx="1703451" cy="213360"/>
           </a:xfrm>
           <a:prstGeom prst="rect">
             <a:avLst/>
@@ -7272,6 +7293,9 @@
           <a:lstStyle/>
           <a:p>
             <a:pPr>
+              <a:lnSpc>
+                <a:spcPts val="1680"/>
+              </a:lnSpc>
               <a:buNone/>
             </a:pPr>
             <a:r>
@@ -7295,8 +7319,8 @@
         </p:nvSpPr>
         <p:spPr>
           <a:xfrm>
-            <a:off x="914781" y="1458849"/>
-            <a:ext cx="5842762" cy="370840"/>
+            <a:off x="914781" y="1431290"/>
+            <a:ext cx="5842762" cy="400050"/>
           </a:xfrm>
           <a:prstGeom prst="rect">
             <a:avLst/>
@@ -7345,8 +7369,8 @@
         </p:nvSpPr>
         <p:spPr>
           <a:xfrm>
-            <a:off x="914781" y="1989836"/>
-            <a:ext cx="1754886" cy="185039"/>
+            <a:off x="914781" y="1978660"/>
+            <a:ext cx="1754886" cy="198120"/>
           </a:xfrm>
           <a:prstGeom prst="rect">
             <a:avLst/>
@@ -7363,6 +7387,9 @@
           <a:lstStyle/>
           <a:p>
             <a:pPr>
+              <a:lnSpc>
+                <a:spcPts val="1560"/>
+              </a:lnSpc>
               <a:buNone/>
             </a:pPr>
             <a:r>
@@ -7386,8 +7413,8 @@
         </p:nvSpPr>
         <p:spPr>
           <a:xfrm>
-            <a:off x="914781" y="2204593"/>
-            <a:ext cx="5920232" cy="374777"/>
+            <a:off x="914781" y="2180209"/>
+            <a:ext cx="5920232" cy="400812"/>
           </a:xfrm>
           <a:prstGeom prst="rect">
             <a:avLst/>
@@ -7405,7 +7432,7 @@
           <a:p>
             <a:pPr marL="0" indent="273304">
               <a:lnSpc>
-                <a:spcPts val="1606"/>
+                <a:spcPts val="1578"/>
               </a:lnSpc>
               <a:buNone/>
             </a:pPr>
@@ -7464,8 +7491,8 @@
         </p:nvSpPr>
         <p:spPr>
           <a:xfrm>
-            <a:off x="914781" y="2736342"/>
-            <a:ext cx="743331" cy="185039"/>
+            <a:off x="914781" y="2725166"/>
+            <a:ext cx="743331" cy="198120"/>
           </a:xfrm>
           <a:prstGeom prst="rect">
             <a:avLst/>
@@ -7482,6 +7509,9 @@
           <a:lstStyle/>
           <a:p>
             <a:pPr>
+              <a:lnSpc>
+                <a:spcPts val="1560"/>
+              </a:lnSpc>
               <a:buNone/>
             </a:pPr>
             <a:r>
@@ -7505,8 +7535,8 @@
         </p:nvSpPr>
         <p:spPr>
           <a:xfrm>
-            <a:off x="1188085" y="2804160"/>
-            <a:ext cx="529971" cy="833247"/>
+            <a:off x="1188085" y="2753995"/>
+            <a:ext cx="529971" cy="891540"/>
           </a:xfrm>
           <a:prstGeom prst="rect">
             <a:avLst/>
@@ -7523,6 +7553,9 @@
           <a:lstStyle/>
           <a:p>
             <a:pPr>
+              <a:lnSpc>
+                <a:spcPts val="7020"/>
+              </a:lnSpc>
               <a:buNone/>
             </a:pPr>
             <a:r>
@@ -7543,8 +7576,8 @@
         </p:nvSpPr>
         <p:spPr>
           <a:xfrm>
-            <a:off x="1718310" y="2954655"/>
-            <a:ext cx="5073650" cy="574294"/>
+            <a:off x="1718310" y="2925382"/>
+            <a:ext cx="5073650" cy="605219"/>
           </a:xfrm>
           <a:prstGeom prst="rect">
             <a:avLst/>
@@ -7602,8 +7635,8 @@
         </p:nvSpPr>
         <p:spPr>
           <a:xfrm>
-            <a:off x="914781" y="3685921"/>
-            <a:ext cx="413766" cy="185039"/>
+            <a:off x="914781" y="3674745"/>
+            <a:ext cx="413766" cy="198120"/>
           </a:xfrm>
           <a:prstGeom prst="rect">
             <a:avLst/>
@@ -7620,6 +7653,9 @@
           <a:lstStyle/>
           <a:p>
             <a:pPr>
+              <a:lnSpc>
+                <a:spcPts val="1560"/>
+              </a:lnSpc>
               <a:buNone/>
             </a:pPr>
             <a:r>
@@ -7643,8 +7679,8 @@
         </p:nvSpPr>
         <p:spPr>
           <a:xfrm>
-            <a:off x="914781" y="3904234"/>
-            <a:ext cx="5929630" cy="774319"/>
+            <a:off x="914781" y="3875532"/>
+            <a:ext cx="5929630" cy="804672"/>
           </a:xfrm>
           <a:prstGeom prst="rect">
             <a:avLst/>
@@ -7736,8 +7772,8 @@
         </p:nvSpPr>
         <p:spPr>
           <a:xfrm>
-            <a:off x="914781" y="4838700"/>
-            <a:ext cx="1415796" cy="185039"/>
+            <a:off x="914781" y="4827524"/>
+            <a:ext cx="1415796" cy="198120"/>
           </a:xfrm>
           <a:prstGeom prst="rect">
             <a:avLst/>
@@ -7754,6 +7790,9 @@
           <a:lstStyle/>
           <a:p>
             <a:pPr>
+              <a:lnSpc>
+                <a:spcPts val="1560"/>
+              </a:lnSpc>
               <a:buNone/>
             </a:pPr>
             <a:r>
@@ -7777,8 +7816,8 @@
         </p:nvSpPr>
         <p:spPr>
           <a:xfrm>
-            <a:off x="914781" y="5057013"/>
-            <a:ext cx="5545963" cy="370840"/>
+            <a:off x="914781" y="5029454"/>
+            <a:ext cx="5545963" cy="400050"/>
           </a:xfrm>
           <a:prstGeom prst="rect">
             <a:avLst/>
@@ -7827,8 +7866,8 @@
         </p:nvSpPr>
         <p:spPr>
           <a:xfrm>
-            <a:off x="1188085" y="5608066"/>
-            <a:ext cx="5662295" cy="142367"/>
+            <a:off x="1188085" y="5599430"/>
+            <a:ext cx="5662295" cy="152400"/>
           </a:xfrm>
           <a:prstGeom prst="rect">
             <a:avLst/>
@@ -7845,6 +7884,9 @@
           <a:lstStyle/>
           <a:p>
             <a:pPr>
+              <a:lnSpc>
+                <a:spcPts val="1200"/>
+              </a:lnSpc>
               <a:buNone/>
             </a:pPr>
             <a:r>
@@ -7865,8 +7907,8 @@
         </p:nvSpPr>
         <p:spPr>
           <a:xfrm>
-            <a:off x="1188085" y="5928741"/>
-            <a:ext cx="5662295" cy="142367"/>
+            <a:off x="1188085" y="5920105"/>
+            <a:ext cx="5662295" cy="152400"/>
           </a:xfrm>
           <a:prstGeom prst="rect">
             <a:avLst/>
@@ -7883,6 +7925,9 @@
           <a:lstStyle/>
           <a:p>
             <a:pPr>
+              <a:lnSpc>
+                <a:spcPts val="1200"/>
+              </a:lnSpc>
               <a:buNone/>
             </a:pPr>
             <a:r>
@@ -7903,8 +7948,8 @@
         </p:nvSpPr>
         <p:spPr>
           <a:xfrm>
-            <a:off x="1340485" y="6173216"/>
-            <a:ext cx="5509387" cy="142367"/>
+            <a:off x="1340485" y="6164580"/>
+            <a:ext cx="5509387" cy="152400"/>
           </a:xfrm>
           <a:prstGeom prst="rect">
             <a:avLst/>
@@ -7921,6 +7966,9 @@
           <a:lstStyle/>
           <a:p>
             <a:pPr>
+              <a:lnSpc>
+                <a:spcPts val="1200"/>
+              </a:lnSpc>
               <a:buNone/>
             </a:pPr>
             <a:r>
@@ -7941,8 +7989,8 @@
         </p:nvSpPr>
         <p:spPr>
           <a:xfrm>
-            <a:off x="1340485" y="6417945"/>
-            <a:ext cx="5509387" cy="142367"/>
+            <a:off x="1340485" y="6409309"/>
+            <a:ext cx="5509387" cy="152400"/>
           </a:xfrm>
           <a:prstGeom prst="rect">
             <a:avLst/>
@@ -7959,6 +8007,9 @@
           <a:lstStyle/>
           <a:p>
             <a:pPr>
+              <a:lnSpc>
+                <a:spcPts val="1200"/>
+              </a:lnSpc>
               <a:buNone/>
             </a:pPr>
             <a:r>
@@ -7979,8 +8030,8 @@
         </p:nvSpPr>
         <p:spPr>
           <a:xfrm>
-            <a:off x="1340485" y="6662420"/>
-            <a:ext cx="5509387" cy="142367"/>
+            <a:off x="1340485" y="6653784"/>
+            <a:ext cx="5509387" cy="152400"/>
           </a:xfrm>
           <a:prstGeom prst="rect">
             <a:avLst/>
@@ -7997,6 +8048,9 @@
           <a:lstStyle/>
           <a:p>
             <a:pPr>
+              <a:lnSpc>
+                <a:spcPts val="1200"/>
+              </a:lnSpc>
               <a:buNone/>
             </a:pPr>
             <a:r>
@@ -8017,8 +8071,8 @@
         </p:nvSpPr>
         <p:spPr>
           <a:xfrm>
-            <a:off x="1188085" y="6983095"/>
-            <a:ext cx="5662295" cy="142367"/>
+            <a:off x="1188085" y="6974459"/>
+            <a:ext cx="5662295" cy="152400"/>
           </a:xfrm>
           <a:prstGeom prst="rect">
             <a:avLst/>
@@ -8035,6 +8089,9 @@
           <a:lstStyle/>
           <a:p>
             <a:pPr>
+              <a:lnSpc>
+                <a:spcPts val="1200"/>
+              </a:lnSpc>
               <a:buNone/>
             </a:pPr>
             <a:r>
@@ -8055,8 +8112,8 @@
         </p:nvSpPr>
         <p:spPr>
           <a:xfrm>
-            <a:off x="1188085" y="7300595"/>
-            <a:ext cx="5662295" cy="142367"/>
+            <a:off x="1188085" y="7291959"/>
+            <a:ext cx="5662295" cy="152400"/>
           </a:xfrm>
           <a:prstGeom prst="rect">
             <a:avLst/>
@@ -8073,6 +8130,9 @@
           <a:lstStyle/>
           <a:p>
             <a:pPr>
+              <a:lnSpc>
+                <a:spcPts val="1200"/>
+              </a:lnSpc>
               <a:buNone/>
             </a:pPr>
             <a:r>
@@ -8093,8 +8153,8 @@
         </p:nvSpPr>
         <p:spPr>
           <a:xfrm>
-            <a:off x="1340485" y="7545451"/>
-            <a:ext cx="5509387" cy="142367"/>
+            <a:off x="1340485" y="7536815"/>
+            <a:ext cx="5509387" cy="152400"/>
           </a:xfrm>
           <a:prstGeom prst="rect">
             <a:avLst/>
@@ -8111,6 +8171,9 @@
           <a:lstStyle/>
           <a:p>
             <a:pPr>
+              <a:lnSpc>
+                <a:spcPts val="1200"/>
+              </a:lnSpc>
               <a:buNone/>
             </a:pPr>
             <a:r>
@@ -8131,8 +8194,8 @@
         </p:nvSpPr>
         <p:spPr>
           <a:xfrm>
-            <a:off x="1340485" y="7789926"/>
-            <a:ext cx="5509387" cy="142367"/>
+            <a:off x="1340485" y="7781290"/>
+            <a:ext cx="5509387" cy="152400"/>
           </a:xfrm>
           <a:prstGeom prst="rect">
             <a:avLst/>
@@ -8149,6 +8212,9 @@
           <a:lstStyle/>
           <a:p>
             <a:pPr>
+              <a:lnSpc>
+                <a:spcPts val="1200"/>
+              </a:lnSpc>
               <a:buNone/>
             </a:pPr>
             <a:r>
@@ -8169,8 +8235,8 @@
         </p:nvSpPr>
         <p:spPr>
           <a:xfrm>
-            <a:off x="1340485" y="8034401"/>
-            <a:ext cx="5509387" cy="142367"/>
+            <a:off x="1340485" y="8025765"/>
+            <a:ext cx="5509387" cy="152400"/>
           </a:xfrm>
           <a:prstGeom prst="rect">
             <a:avLst/>
@@ -8187,6 +8253,9 @@
           <a:lstStyle/>
           <a:p>
             <a:pPr>
+              <a:lnSpc>
+                <a:spcPts val="1200"/>
+              </a:lnSpc>
               <a:buNone/>
             </a:pPr>
             <a:r>
@@ -8207,8 +8276,8 @@
         </p:nvSpPr>
         <p:spPr>
           <a:xfrm>
-            <a:off x="1340485" y="8278876"/>
-            <a:ext cx="5509387" cy="142367"/>
+            <a:off x="1340485" y="8270240"/>
+            <a:ext cx="5509387" cy="152400"/>
           </a:xfrm>
           <a:prstGeom prst="rect">
             <a:avLst/>
@@ -8225,6 +8294,9 @@
           <a:lstStyle/>
           <a:p>
             <a:pPr>
+              <a:lnSpc>
+                <a:spcPts val="1200"/>
+              </a:lnSpc>
               <a:buNone/>
             </a:pPr>
             <a:r>
@@ -8245,8 +8317,8 @@
         </p:nvSpPr>
         <p:spPr>
           <a:xfrm>
-            <a:off x="914781" y="8707882"/>
-            <a:ext cx="5631942" cy="437515"/>
+            <a:off x="914781" y="8708771"/>
+            <a:ext cx="5631942" cy="438150"/>
           </a:xfrm>
           <a:prstGeom prst="rect">
             <a:avLst/>
@@ -8337,8 +8409,8 @@
         </p:nvSpPr>
         <p:spPr>
           <a:xfrm>
-            <a:off x="1188085" y="917067"/>
-            <a:ext cx="5662295" cy="142367"/>
+            <a:off x="1188085" y="908431"/>
+            <a:ext cx="5662295" cy="152400"/>
           </a:xfrm>
           <a:prstGeom prst="rect">
             <a:avLst/>
@@ -8355,6 +8427,9 @@
           <a:lstStyle/>
           <a:p>
             <a:pPr>
+              <a:lnSpc>
+                <a:spcPts val="1200"/>
+              </a:lnSpc>
               <a:buNone/>
             </a:pPr>
             <a:r>
@@ -8375,8 +8450,8 @@
         </p:nvSpPr>
         <p:spPr>
           <a:xfrm>
-            <a:off x="1188085" y="1237742"/>
-            <a:ext cx="5662295" cy="142367"/>
+            <a:off x="1188085" y="1229106"/>
+            <a:ext cx="5662295" cy="152400"/>
           </a:xfrm>
           <a:prstGeom prst="rect">
             <a:avLst/>
@@ -8393,6 +8468,9 @@
           <a:lstStyle/>
           <a:p>
             <a:pPr>
+              <a:lnSpc>
+                <a:spcPts val="1200"/>
+              </a:lnSpc>
               <a:buNone/>
             </a:pPr>
             <a:r>
@@ -8413,8 +8491,8 @@
         </p:nvSpPr>
         <p:spPr>
           <a:xfrm>
-            <a:off x="1340485" y="1482471"/>
-            <a:ext cx="5509387" cy="142367"/>
+            <a:off x="1340485" y="1473835"/>
+            <a:ext cx="5509387" cy="152400"/>
           </a:xfrm>
           <a:prstGeom prst="rect">
             <a:avLst/>
@@ -8431,6 +8509,9 @@
           <a:lstStyle/>
           <a:p>
             <a:pPr>
+              <a:lnSpc>
+                <a:spcPts val="1200"/>
+              </a:lnSpc>
               <a:buNone/>
             </a:pPr>
             <a:r>
@@ -8451,8 +8532,8 @@
         </p:nvSpPr>
         <p:spPr>
           <a:xfrm>
-            <a:off x="1340485" y="1726946"/>
-            <a:ext cx="5509387" cy="142367"/>
+            <a:off x="1340485" y="1718310"/>
+            <a:ext cx="5509387" cy="152400"/>
           </a:xfrm>
           <a:prstGeom prst="rect">
             <a:avLst/>
@@ -8469,6 +8550,9 @@
           <a:lstStyle/>
           <a:p>
             <a:pPr>
+              <a:lnSpc>
+                <a:spcPts val="1200"/>
+              </a:lnSpc>
               <a:buNone/>
             </a:pPr>
             <a:r>
@@ -8489,8 +8573,8 @@
         </p:nvSpPr>
         <p:spPr>
           <a:xfrm>
-            <a:off x="1340485" y="1968246"/>
-            <a:ext cx="5509387" cy="142367"/>
+            <a:off x="1340485" y="1959610"/>
+            <a:ext cx="5509387" cy="152400"/>
           </a:xfrm>
           <a:prstGeom prst="rect">
             <a:avLst/>
@@ -8507,6 +8591,9 @@
           <a:lstStyle/>
           <a:p>
             <a:pPr>
+              <a:lnSpc>
+                <a:spcPts val="1200"/>
+              </a:lnSpc>
               <a:buNone/>
             </a:pPr>
             <a:r>
@@ -8527,8 +8614,8 @@
         </p:nvSpPr>
         <p:spPr>
           <a:xfrm>
-            <a:off x="1340485" y="2212721"/>
-            <a:ext cx="5509387" cy="142367"/>
+            <a:off x="1340485" y="2204085"/>
+            <a:ext cx="5509387" cy="152400"/>
           </a:xfrm>
           <a:prstGeom prst="rect">
             <a:avLst/>
@@ -8545,6 +8632,9 @@
           <a:lstStyle/>
           <a:p>
             <a:pPr>
+              <a:lnSpc>
+                <a:spcPts val="1200"/>
+              </a:lnSpc>
               <a:buNone/>
             </a:pPr>
             <a:r>
@@ -8590,8 +8680,8 @@
         </p:nvSpPr>
         <p:spPr>
           <a:xfrm>
-            <a:off x="3586226" y="1225296"/>
-            <a:ext cx="603250" cy="199263"/>
+            <a:off x="3586226" y="1213231"/>
+            <a:ext cx="603250" cy="213360"/>
           </a:xfrm>
           <a:prstGeom prst="rect">
             <a:avLst/>
@@ -8608,6 +8698,9 @@
           <a:lstStyle/>
           <a:p>
             <a:pPr>
+              <a:lnSpc>
+                <a:spcPts val="1680"/>
+              </a:lnSpc>
               <a:buNone/>
             </a:pPr>
             <a:r>
@@ -8631,8 +8724,8 @@
         </p:nvSpPr>
         <p:spPr>
           <a:xfrm>
-            <a:off x="914781" y="1458849"/>
-            <a:ext cx="5698617" cy="370840"/>
+            <a:off x="914781" y="1431290"/>
+            <a:ext cx="5698617" cy="400050"/>
           </a:xfrm>
           <a:prstGeom prst="rect">
             <a:avLst/>
@@ -8705,8 +8798,8 @@
         </p:nvSpPr>
         <p:spPr>
           <a:xfrm>
-            <a:off x="914781" y="6101969"/>
-            <a:ext cx="5876925" cy="571119"/>
+            <a:off x="914781" y="6074283"/>
+            <a:ext cx="5876925" cy="600456"/>
           </a:xfrm>
           <a:prstGeom prst="rect">
             <a:avLst/>
@@ -8825,8 +8918,8 @@
         </p:nvSpPr>
         <p:spPr>
           <a:xfrm>
-            <a:off x="914781" y="8269478"/>
-            <a:ext cx="5797042" cy="434594"/>
+            <a:off x="914781" y="8271701"/>
+            <a:ext cx="5797042" cy="433768"/>
           </a:xfrm>
           <a:prstGeom prst="rect">
             <a:avLst/>
@@ -8844,7 +8937,7 @@
           <a:p>
             <a:pPr marL="0" indent="273304">
               <a:lnSpc>
-                <a:spcPts val="1150"/>
+                <a:spcPts val="1138"/>
               </a:lnSpc>
               <a:buNone/>
             </a:pPr>
@@ -8890,8 +8983,8 @@
         </p:nvSpPr>
         <p:spPr>
           <a:xfrm>
-            <a:off x="3684651" y="1225296"/>
-            <a:ext cx="403606" cy="199263"/>
+            <a:off x="3684651" y="1213231"/>
+            <a:ext cx="403606" cy="213360"/>
           </a:xfrm>
           <a:prstGeom prst="rect">
             <a:avLst/>
@@ -8908,6 +9001,9 @@
           <a:lstStyle/>
           <a:p>
             <a:pPr>
+              <a:lnSpc>
+                <a:spcPts val="1680"/>
+              </a:lnSpc>
               <a:buNone/>
             </a:pPr>
             <a:r>
@@ -8931,8 +9027,8 @@
         </p:nvSpPr>
         <p:spPr>
           <a:xfrm>
-            <a:off x="914781" y="1458849"/>
-            <a:ext cx="5823585" cy="370840"/>
+            <a:off x="914781" y="1431290"/>
+            <a:ext cx="5823585" cy="400050"/>
           </a:xfrm>
           <a:prstGeom prst="rect">
             <a:avLst/>
@@ -8981,8 +9077,8 @@
         </p:nvSpPr>
         <p:spPr>
           <a:xfrm>
-            <a:off x="914781" y="1989836"/>
-            <a:ext cx="1009396" cy="185039"/>
+            <a:off x="914781" y="1978660"/>
+            <a:ext cx="1009396" cy="198120"/>
           </a:xfrm>
           <a:prstGeom prst="rect">
             <a:avLst/>
@@ -8999,6 +9095,9 @@
           <a:lstStyle/>
           <a:p>
             <a:pPr>
+              <a:lnSpc>
+                <a:spcPts val="1560"/>
+              </a:lnSpc>
               <a:buNone/>
             </a:pPr>
             <a:r>
@@ -9022,8 +9121,8 @@
         </p:nvSpPr>
         <p:spPr>
           <a:xfrm>
-            <a:off x="1416685" y="2217674"/>
-            <a:ext cx="519938" cy="170815"/>
+            <a:off x="1416685" y="2207260"/>
+            <a:ext cx="519938" cy="182880"/>
           </a:xfrm>
           <a:prstGeom prst="rect">
             <a:avLst/>
@@ -9040,6 +9139,9 @@
           <a:lstStyle/>
           <a:p>
             <a:pPr marL="228600" indent="-177800">
+              <a:lnSpc>
+                <a:spcPts val="1440"/>
+              </a:lnSpc>
               <a:buFont typeface="Arial"/>
               <a:buChar char="•"/>
             </a:pPr>
@@ -9061,8 +9163,8 @@
         </p:nvSpPr>
         <p:spPr>
           <a:xfrm>
-            <a:off x="1416685" y="2424430"/>
-            <a:ext cx="521716" cy="170815"/>
+            <a:off x="1416685" y="2414016"/>
+            <a:ext cx="521716" cy="182880"/>
           </a:xfrm>
           <a:prstGeom prst="rect">
             <a:avLst/>
@@ -9079,6 +9181,9 @@
           <a:lstStyle/>
           <a:p>
             <a:pPr marL="228600" indent="-177800">
+              <a:lnSpc>
+                <a:spcPts val="1440"/>
+              </a:lnSpc>
               <a:buFont typeface="Arial"/>
               <a:buChar char="•"/>
             </a:pPr>
@@ -9100,8 +9205,8 @@
         </p:nvSpPr>
         <p:spPr>
           <a:xfrm>
-            <a:off x="914781" y="2752217"/>
-            <a:ext cx="1155319" cy="185039"/>
+            <a:off x="914781" y="2741041"/>
+            <a:ext cx="1155319" cy="198120"/>
           </a:xfrm>
           <a:prstGeom prst="rect">
             <a:avLst/>
@@ -9118,6 +9223,9 @@
           <a:lstStyle/>
           <a:p>
             <a:pPr>
+              <a:lnSpc>
+                <a:spcPts val="1560"/>
+              </a:lnSpc>
               <a:buNone/>
             </a:pPr>
             <a:r>
@@ -9141,8 +9249,8 @@
         </p:nvSpPr>
         <p:spPr>
           <a:xfrm>
-            <a:off x="1416685" y="2967355"/>
-            <a:ext cx="5271516" cy="374015"/>
+            <a:off x="1416685" y="2936621"/>
+            <a:ext cx="5271516" cy="406400"/>
           </a:xfrm>
           <a:prstGeom prst="rect">
             <a:avLst/>
@@ -9197,8 +9305,8 @@
         </p:nvSpPr>
         <p:spPr>
           <a:xfrm>
-            <a:off x="1416685" y="3370834"/>
-            <a:ext cx="521716" cy="170815"/>
+            <a:off x="1416685" y="3360420"/>
+            <a:ext cx="521716" cy="182880"/>
           </a:xfrm>
           <a:prstGeom prst="rect">
             <a:avLst/>
@@ -9215,6 +9323,9 @@
           <a:lstStyle/>
           <a:p>
             <a:pPr marL="228600" indent="-177800">
+              <a:lnSpc>
+                <a:spcPts val="1440"/>
+              </a:lnSpc>
               <a:buNone/>
             </a:pPr>
             <a:r>
@@ -9241,8 +9352,8 @@
         </p:nvSpPr>
         <p:spPr>
           <a:xfrm>
-            <a:off x="914781" y="3701796"/>
-            <a:ext cx="1274572" cy="185039"/>
+            <a:off x="914781" y="3690620"/>
+            <a:ext cx="1274572" cy="198120"/>
           </a:xfrm>
           <a:prstGeom prst="rect">
             <a:avLst/>
@@ -9259,6 +9370,9 @@
           <a:lstStyle/>
           <a:p>
             <a:pPr>
+              <a:lnSpc>
+                <a:spcPts val="1560"/>
+              </a:lnSpc>
               <a:buNone/>
             </a:pPr>
             <a:r>
@@ -9282,8 +9396,8 @@
         </p:nvSpPr>
         <p:spPr>
           <a:xfrm>
-            <a:off x="1143635" y="3916934"/>
-            <a:ext cx="519938" cy="170815"/>
+            <a:off x="1143635" y="3906520"/>
+            <a:ext cx="519938" cy="182880"/>
           </a:xfrm>
           <a:prstGeom prst="rect">
             <a:avLst/>
@@ -9300,6 +9414,9 @@
           <a:lstStyle/>
           <a:p>
             <a:pPr marL="228600" indent="-177800">
+              <a:lnSpc>
+                <a:spcPts val="1440"/>
+              </a:lnSpc>
               <a:buNone/>
             </a:pPr>
             <a:r>
@@ -9326,8 +9443,8 @@
         </p:nvSpPr>
         <p:spPr>
           <a:xfrm>
-            <a:off x="1188085" y="4120134"/>
-            <a:ext cx="750316" cy="170815"/>
+            <a:off x="1188085" y="4109720"/>
+            <a:ext cx="750316" cy="182880"/>
           </a:xfrm>
           <a:prstGeom prst="rect">
             <a:avLst/>
@@ -9344,6 +9461,9 @@
           <a:lstStyle/>
           <a:p>
             <a:pPr marL="457200" indent="-177800" lvl="1">
+              <a:lnSpc>
+                <a:spcPts val="1440"/>
+              </a:lnSpc>
               <a:buNone/>
             </a:pPr>
             <a:r>
@@ -9370,8 +9490,8 @@
         </p:nvSpPr>
         <p:spPr>
           <a:xfrm>
-            <a:off x="1601216" y="4320159"/>
-            <a:ext cx="1088136" cy="170815"/>
+            <a:off x="1601216" y="4309745"/>
+            <a:ext cx="1088136" cy="182880"/>
           </a:xfrm>
           <a:prstGeom prst="rect">
             <a:avLst/>
@@ -9388,6 +9508,9 @@
           <a:lstStyle/>
           <a:p>
             <a:pPr marL="685800" indent="-177800" lvl="2">
+              <a:lnSpc>
+                <a:spcPts val="1440"/>
+              </a:lnSpc>
               <a:buNone/>
             </a:pPr>
             <a:r>
@@ -9414,8 +9537,8 @@
         </p:nvSpPr>
         <p:spPr>
           <a:xfrm>
-            <a:off x="1236091" y="4523613"/>
-            <a:ext cx="5571998" cy="370840"/>
+            <a:off x="1236091" y="4496054"/>
+            <a:ext cx="5571998" cy="400050"/>
           </a:xfrm>
           <a:prstGeom prst="rect">
             <a:avLst/>
@@ -9470,8 +9593,8 @@
         </p:nvSpPr>
         <p:spPr>
           <a:xfrm>
-            <a:off x="1601216" y="4926838"/>
-            <a:ext cx="967740" cy="170815"/>
+            <a:off x="1601216" y="4916424"/>
+            <a:ext cx="967740" cy="182880"/>
           </a:xfrm>
           <a:prstGeom prst="rect">
             <a:avLst/>
@@ -9488,6 +9611,9 @@
           <a:lstStyle/>
           <a:p>
             <a:pPr marL="685800" indent="-177800" lvl="2">
+              <a:lnSpc>
+                <a:spcPts val="1440"/>
+              </a:lnSpc>
               <a:buNone/>
             </a:pPr>
             <a:r>
@@ -9514,8 +9640,8 @@
         </p:nvSpPr>
         <p:spPr>
           <a:xfrm>
-            <a:off x="1143635" y="5126863"/>
-            <a:ext cx="427482" cy="170815"/>
+            <a:off x="1143635" y="5116449"/>
+            <a:ext cx="427482" cy="182880"/>
           </a:xfrm>
           <a:prstGeom prst="rect">
             <a:avLst/>
@@ -9532,6 +9658,9 @@
           <a:lstStyle/>
           <a:p>
             <a:pPr marL="228600" indent="-177800">
+              <a:lnSpc>
+                <a:spcPts val="1440"/>
+              </a:lnSpc>
               <a:buNone/>
             </a:pPr>
             <a:r>
@@ -9558,8 +9687,8 @@
         </p:nvSpPr>
         <p:spPr>
           <a:xfrm>
-            <a:off x="1143635" y="5326888"/>
-            <a:ext cx="2002155" cy="170815"/>
+            <a:off x="1143635" y="5316474"/>
+            <a:ext cx="2002155" cy="182880"/>
           </a:xfrm>
           <a:prstGeom prst="rect">
             <a:avLst/>
@@ -9576,6 +9705,9 @@
           <a:lstStyle/>
           <a:p>
             <a:pPr>
+              <a:lnSpc>
+                <a:spcPts val="1440"/>
+              </a:lnSpc>
               <a:buNone/>
             </a:pPr>
             <a:r>
@@ -9596,8 +9728,8 @@
         </p:nvSpPr>
         <p:spPr>
           <a:xfrm>
-            <a:off x="1143635" y="5530469"/>
-            <a:ext cx="519938" cy="170815"/>
+            <a:off x="1143635" y="5520055"/>
+            <a:ext cx="519938" cy="182880"/>
           </a:xfrm>
           <a:prstGeom prst="rect">
             <a:avLst/>
@@ -9614,6 +9746,9 @@
           <a:lstStyle/>
           <a:p>
             <a:pPr marL="228600" indent="-177800">
+              <a:lnSpc>
+                <a:spcPts val="1440"/>
+              </a:lnSpc>
               <a:buFont typeface="Arial"/>
               <a:buChar char="▪"/>
             </a:pPr>
@@ -9635,8 +9770,8 @@
         </p:nvSpPr>
         <p:spPr>
           <a:xfrm>
-            <a:off x="1143635" y="5740019"/>
-            <a:ext cx="750316" cy="170815"/>
+            <a:off x="1143635" y="5729605"/>
+            <a:ext cx="750316" cy="182880"/>
           </a:xfrm>
           <a:prstGeom prst="rect">
             <a:avLst/>
@@ -9653,6 +9788,9 @@
           <a:lstStyle/>
           <a:p>
             <a:pPr marL="457200" indent="-177800" lvl="1">
+              <a:lnSpc>
+                <a:spcPts val="1440"/>
+              </a:lnSpc>
               <a:buFont typeface="Arial"/>
               <a:buChar char="•"/>
             </a:pPr>
@@ -9674,8 +9812,8 @@
         </p:nvSpPr>
         <p:spPr>
           <a:xfrm>
-            <a:off x="1143635" y="5940044"/>
-            <a:ext cx="3653028" cy="170815"/>
+            <a:off x="1143635" y="5929630"/>
+            <a:ext cx="3653028" cy="182880"/>
           </a:xfrm>
           <a:prstGeom prst="rect">
             <a:avLst/>
@@ -9692,6 +9830,9 @@
           <a:lstStyle/>
           <a:p>
             <a:pPr marL="685800" indent="-177800" lvl="2">
+              <a:lnSpc>
+                <a:spcPts val="1440"/>
+              </a:lnSpc>
               <a:buFont typeface="Arial"/>
               <a:buChar char="•"/>
             </a:pPr>
@@ -9713,8 +9854,8 @@
         </p:nvSpPr>
         <p:spPr>
           <a:xfrm>
-            <a:off x="1144016" y="6140069"/>
-            <a:ext cx="1233170" cy="170815"/>
+            <a:off x="1144016" y="6129655"/>
+            <a:ext cx="1233170" cy="182880"/>
           </a:xfrm>
           <a:prstGeom prst="rect">
             <a:avLst/>
@@ -9731,6 +9872,9 @@
           <a:lstStyle/>
           <a:p>
             <a:pPr marL="914400" indent="-177800" lvl="3">
+              <a:lnSpc>
+                <a:spcPts val="1440"/>
+              </a:lnSpc>
               <a:buFont typeface="Arial"/>
               <a:buChar char="o"/>
             </a:pPr>
@@ -9752,8 +9896,8 @@
         </p:nvSpPr>
         <p:spPr>
           <a:xfrm>
-            <a:off x="1143635" y="6343269"/>
-            <a:ext cx="510540" cy="170815"/>
+            <a:off x="1143635" y="6332855"/>
+            <a:ext cx="510540" cy="182880"/>
           </a:xfrm>
           <a:prstGeom prst="rect">
             <a:avLst/>
@@ -9770,6 +9914,9 @@
           <a:lstStyle/>
           <a:p>
             <a:pPr marL="228600" indent="-177800">
+              <a:lnSpc>
+                <a:spcPts val="1440"/>
+              </a:lnSpc>
               <a:buFont typeface="Arial"/>
               <a:buChar char="▪"/>
             </a:pPr>
@@ -9791,8 +9938,8 @@
         </p:nvSpPr>
         <p:spPr>
           <a:xfrm>
-            <a:off x="914781" y="6671310"/>
-            <a:ext cx="1228852" cy="185039"/>
+            <a:off x="914781" y="6660134"/>
+            <a:ext cx="1228852" cy="198120"/>
           </a:xfrm>
           <a:prstGeom prst="rect">
             <a:avLst/>
@@ -9809,6 +9956,9 @@
           <a:lstStyle/>
           <a:p>
             <a:pPr>
+              <a:lnSpc>
+                <a:spcPts val="1560"/>
+              </a:lnSpc>
               <a:buNone/>
             </a:pPr>
             <a:r>
@@ -9832,8 +9982,8 @@
         </p:nvSpPr>
         <p:spPr>
           <a:xfrm>
-            <a:off x="1416685" y="6889623"/>
-            <a:ext cx="519938" cy="170815"/>
+            <a:off x="1416685" y="6879209"/>
+            <a:ext cx="519938" cy="182880"/>
           </a:xfrm>
           <a:prstGeom prst="rect">
             <a:avLst/>
@@ -9850,6 +10000,9 @@
           <a:lstStyle/>
           <a:p>
             <a:pPr marL="228600" indent="-177800">
+              <a:lnSpc>
+                <a:spcPts val="1440"/>
+              </a:lnSpc>
               <a:buNone/>
             </a:pPr>
             <a:r>
@@ -9876,8 +10029,8 @@
         </p:nvSpPr>
         <p:spPr>
           <a:xfrm>
-            <a:off x="1416685" y="7089648"/>
-            <a:ext cx="521716" cy="170815"/>
+            <a:off x="1416685" y="7079234"/>
+            <a:ext cx="521716" cy="182880"/>
           </a:xfrm>
           <a:prstGeom prst="rect">
             <a:avLst/>
@@ -9894,6 +10047,9 @@
           <a:lstStyle/>
           <a:p>
             <a:pPr marL="228600" indent="-177800">
+              <a:lnSpc>
+                <a:spcPts val="1440"/>
+              </a:lnSpc>
               <a:buNone/>
             </a:pPr>
             <a:r>
@@ -9920,8 +10076,8 @@
         </p:nvSpPr>
         <p:spPr>
           <a:xfrm>
-            <a:off x="1372235" y="7292975"/>
-            <a:ext cx="5188712" cy="371094"/>
+            <a:off x="1372235" y="7265162"/>
+            <a:ext cx="5188712" cy="400558"/>
           </a:xfrm>
           <a:prstGeom prst="rect">
             <a:avLst/>
@@ -9970,8 +10126,8 @@
         </p:nvSpPr>
         <p:spPr>
           <a:xfrm>
-            <a:off x="1416685" y="7696454"/>
-            <a:ext cx="3107690" cy="170815"/>
+            <a:off x="1416685" y="7686040"/>
+            <a:ext cx="3107690" cy="182880"/>
           </a:xfrm>
           <a:prstGeom prst="rect">
             <a:avLst/>
@@ -9988,6 +10144,9 @@
           <a:lstStyle/>
           <a:p>
             <a:pPr marL="228600" indent="-177800">
+              <a:lnSpc>
+                <a:spcPts val="1440"/>
+              </a:lnSpc>
               <a:buNone/>
             </a:pPr>
             <a:r>
@@ -10014,8 +10173,8 @@
         </p:nvSpPr>
         <p:spPr>
           <a:xfrm>
-            <a:off x="1416685" y="7896479"/>
-            <a:ext cx="547370" cy="170815"/>
+            <a:off x="1416685" y="7886065"/>
+            <a:ext cx="547370" cy="182880"/>
           </a:xfrm>
           <a:prstGeom prst="rect">
             <a:avLst/>
@@ -10032,6 +10191,9 @@
           <a:lstStyle/>
           <a:p>
             <a:pPr marL="228600" indent="-177800">
+              <a:lnSpc>
+                <a:spcPts val="1440"/>
+              </a:lnSpc>
               <a:buNone/>
             </a:pPr>
             <a:r>

</xml_diff>